<commit_message>
Site updated: 2022-11-01 10:00:53
</commit_message>
<xml_diff>
--- a/什么是党代会、人大会、两会？什么是几大、几届几中全会？/党代会时间轴.pptx
+++ b/什么是党代会、人大会、两会？什么是几大、几届几中全会？/党代会时间轴.pptx
@@ -241,7 +241,7 @@
           <a:p>
             <a:fld id="{D997B5FA-0921-464F-AAE1-844C04324D75}" type="datetimeFigureOut">
               <a:rPr lang="zh-CN" altLang="en-US" smtClean="0"/>
-              <a:t>2022/10/31</a:t>
+              <a:t>2022/11/1</a:t>
             </a:fld>
             <a:endParaRPr lang="zh-CN" altLang="en-US"/>
           </a:p>
@@ -409,7 +409,7 @@
           <a:p>
             <a:fld id="{D997B5FA-0921-464F-AAE1-844C04324D75}" type="datetimeFigureOut">
               <a:rPr lang="zh-CN" altLang="en-US" smtClean="0"/>
-              <a:t>2022/10/31</a:t>
+              <a:t>2022/11/1</a:t>
             </a:fld>
             <a:endParaRPr lang="zh-CN" altLang="en-US"/>
           </a:p>
@@ -587,7 +587,7 @@
           <a:p>
             <a:fld id="{D997B5FA-0921-464F-AAE1-844C04324D75}" type="datetimeFigureOut">
               <a:rPr lang="zh-CN" altLang="en-US" smtClean="0"/>
-              <a:t>2022/10/31</a:t>
+              <a:t>2022/11/1</a:t>
             </a:fld>
             <a:endParaRPr lang="zh-CN" altLang="en-US"/>
           </a:p>
@@ -755,7 +755,7 @@
           <a:p>
             <a:fld id="{D997B5FA-0921-464F-AAE1-844C04324D75}" type="datetimeFigureOut">
               <a:rPr lang="zh-CN" altLang="en-US" smtClean="0"/>
-              <a:t>2022/10/31</a:t>
+              <a:t>2022/11/1</a:t>
             </a:fld>
             <a:endParaRPr lang="zh-CN" altLang="en-US"/>
           </a:p>
@@ -1000,7 +1000,7 @@
           <a:p>
             <a:fld id="{D997B5FA-0921-464F-AAE1-844C04324D75}" type="datetimeFigureOut">
               <a:rPr lang="zh-CN" altLang="en-US" smtClean="0"/>
-              <a:t>2022/10/31</a:t>
+              <a:t>2022/11/1</a:t>
             </a:fld>
             <a:endParaRPr lang="zh-CN" altLang="en-US"/>
           </a:p>
@@ -1229,7 +1229,7 @@
           <a:p>
             <a:fld id="{D997B5FA-0921-464F-AAE1-844C04324D75}" type="datetimeFigureOut">
               <a:rPr lang="zh-CN" altLang="en-US" smtClean="0"/>
-              <a:t>2022/10/31</a:t>
+              <a:t>2022/11/1</a:t>
             </a:fld>
             <a:endParaRPr lang="zh-CN" altLang="en-US"/>
           </a:p>
@@ -1593,7 +1593,7 @@
           <a:p>
             <a:fld id="{D997B5FA-0921-464F-AAE1-844C04324D75}" type="datetimeFigureOut">
               <a:rPr lang="zh-CN" altLang="en-US" smtClean="0"/>
-              <a:t>2022/10/31</a:t>
+              <a:t>2022/11/1</a:t>
             </a:fld>
             <a:endParaRPr lang="zh-CN" altLang="en-US"/>
           </a:p>
@@ -1710,7 +1710,7 @@
           <a:p>
             <a:fld id="{D997B5FA-0921-464F-AAE1-844C04324D75}" type="datetimeFigureOut">
               <a:rPr lang="zh-CN" altLang="en-US" smtClean="0"/>
-              <a:t>2022/10/31</a:t>
+              <a:t>2022/11/1</a:t>
             </a:fld>
             <a:endParaRPr lang="zh-CN" altLang="en-US"/>
           </a:p>
@@ -1805,7 +1805,7 @@
           <a:p>
             <a:fld id="{D997B5FA-0921-464F-AAE1-844C04324D75}" type="datetimeFigureOut">
               <a:rPr lang="zh-CN" altLang="en-US" smtClean="0"/>
-              <a:t>2022/10/31</a:t>
+              <a:t>2022/11/1</a:t>
             </a:fld>
             <a:endParaRPr lang="zh-CN" altLang="en-US"/>
           </a:p>
@@ -2080,7 +2080,7 @@
           <a:p>
             <a:fld id="{D997B5FA-0921-464F-AAE1-844C04324D75}" type="datetimeFigureOut">
               <a:rPr lang="zh-CN" altLang="en-US" smtClean="0"/>
-              <a:t>2022/10/31</a:t>
+              <a:t>2022/11/1</a:t>
             </a:fld>
             <a:endParaRPr lang="zh-CN" altLang="en-US"/>
           </a:p>
@@ -2332,7 +2332,7 @@
           <a:p>
             <a:fld id="{D997B5FA-0921-464F-AAE1-844C04324D75}" type="datetimeFigureOut">
               <a:rPr lang="zh-CN" altLang="en-US" smtClean="0"/>
-              <a:t>2022/10/31</a:t>
+              <a:t>2022/11/1</a:t>
             </a:fld>
             <a:endParaRPr lang="zh-CN" altLang="en-US"/>
           </a:p>
@@ -2543,7 +2543,7 @@
           <a:p>
             <a:fld id="{D997B5FA-0921-464F-AAE1-844C04324D75}" type="datetimeFigureOut">
               <a:rPr lang="zh-CN" altLang="en-US" smtClean="0"/>
-              <a:t>2022/10/31</a:t>
+              <a:t>2022/11/1</a:t>
             </a:fld>
             <a:endParaRPr lang="zh-CN" altLang="en-US"/>
           </a:p>
@@ -3433,8 +3433,8 @@
         </p:nvCxnSpPr>
         <p:spPr>
           <a:xfrm flipH="1" flipV="1">
-            <a:off x="1539282" y="3128573"/>
-            <a:ext cx="558334" cy="678436"/>
+            <a:off x="1338840" y="2283867"/>
+            <a:ext cx="758776" cy="1523142"/>
           </a:xfrm>
           <a:prstGeom prst="line">
             <a:avLst/>
@@ -3476,7 +3476,7 @@
         </p:nvSpPr>
         <p:spPr>
           <a:xfrm>
-            <a:off x="826330" y="3161673"/>
+            <a:off x="939163" y="2362948"/>
             <a:ext cx="951502" cy="584775"/>
           </a:xfrm>
           <a:prstGeom prst="rect">
@@ -3530,7 +3530,7 @@
         </p:nvSpPr>
         <p:spPr>
           <a:xfrm>
-            <a:off x="586976" y="2683475"/>
+            <a:off x="481784" y="1868836"/>
             <a:ext cx="1262377" cy="461665"/>
           </a:xfrm>
           <a:prstGeom prst="rect">
@@ -3617,7 +3617,7 @@
         <p:spPr>
           <a:xfrm>
             <a:off x="1433016" y="1883759"/>
-            <a:ext cx="1159588" cy="584775"/>
+            <a:ext cx="1159588" cy="523220"/>
           </a:xfrm>
           <a:prstGeom prst="rect">
             <a:avLst/>
@@ -3630,25 +3630,25 @@
           </a:bodyPr>
           <a:lstStyle/>
           <a:p>
-            <a:pPr algn="ctr"/>
-            <a:r>
-              <a:rPr lang="zh-CN" altLang="en-US" sz="1600" dirty="0">
+            <a:pPr algn="r"/>
+            <a:r>
+              <a:rPr lang="zh-CN" altLang="en-US" sz="1400" dirty="0">
                 <a:solidFill>
                   <a:srgbClr val="00B0F0"/>
                 </a:solidFill>
               </a:rPr>
               <a:t>十九届</a:t>
             </a:r>
-            <a:endParaRPr lang="en-US" altLang="zh-CN" sz="1600" dirty="0">
+            <a:endParaRPr lang="en-US" altLang="zh-CN" sz="1400" dirty="0">
               <a:solidFill>
                 <a:srgbClr val="00B0F0"/>
               </a:solidFill>
             </a:endParaRPr>
           </a:p>
           <a:p>
-            <a:pPr algn="ctr"/>
-            <a:r>
-              <a:rPr lang="zh-CN" altLang="en-US" sz="1600" dirty="0">
+            <a:pPr algn="r"/>
+            <a:r>
+              <a:rPr lang="zh-CN" altLang="en-US" sz="1400" dirty="0">
                 <a:solidFill>
                   <a:srgbClr val="00B0F0"/>
                 </a:solidFill>
@@ -3721,7 +3721,7 @@
         <p:spPr>
           <a:xfrm>
             <a:off x="2367506" y="1934232"/>
-            <a:ext cx="1934068" cy="338554"/>
+            <a:ext cx="1934068" cy="307777"/>
           </a:xfrm>
           <a:prstGeom prst="rect">
             <a:avLst/>
@@ -3736,7 +3736,7 @@
           <a:p>
             <a:pPr algn="ctr"/>
             <a:r>
-              <a:rPr lang="zh-CN" altLang="en-US" sz="1600" dirty="0"/>
+              <a:rPr lang="zh-CN" altLang="en-US" sz="1400" dirty="0"/>
               <a:t>十九届二中全会</a:t>
             </a:r>
           </a:p>
@@ -3756,8 +3756,8 @@
         </p:nvSpPr>
         <p:spPr>
           <a:xfrm>
-            <a:off x="1615347" y="2455309"/>
-            <a:ext cx="914400" cy="584775"/>
+            <a:off x="1860342" y="2481454"/>
+            <a:ext cx="832351" cy="584775"/>
           </a:xfrm>
           <a:prstGeom prst="rect">
             <a:avLst/>
@@ -3858,7 +3858,7 @@
         <p:spPr>
           <a:xfrm>
             <a:off x="2830465" y="2285738"/>
-            <a:ext cx="1814094" cy="338554"/>
+            <a:ext cx="1814094" cy="307777"/>
           </a:xfrm>
           <a:prstGeom prst="rect">
             <a:avLst/>
@@ -3873,7 +3873,7 @@
           <a:p>
             <a:pPr algn="ctr"/>
             <a:r>
-              <a:rPr lang="zh-CN" altLang="en-US" sz="1600" dirty="0"/>
+              <a:rPr lang="zh-CN" altLang="en-US" sz="1400" dirty="0"/>
               <a:t>十九届三中全会</a:t>
             </a:r>
           </a:p>
@@ -3983,8 +3983,8 @@
         </p:nvSpPr>
         <p:spPr>
           <a:xfrm>
-            <a:off x="4897118" y="2123916"/>
-            <a:ext cx="1114686" cy="584775"/>
+            <a:off x="4919638" y="2129345"/>
+            <a:ext cx="1114686" cy="523220"/>
           </a:xfrm>
           <a:prstGeom prst="rect">
             <a:avLst/>
@@ -3997,17 +3997,17 @@
           </a:bodyPr>
           <a:lstStyle/>
           <a:p>
-            <a:pPr algn="ctr"/>
-            <a:r>
-              <a:rPr lang="zh-CN" altLang="en-US" sz="1600" dirty="0"/>
+            <a:pPr algn="r"/>
+            <a:r>
+              <a:rPr lang="zh-CN" altLang="en-US" sz="1400" dirty="0"/>
               <a:t>十九届</a:t>
             </a:r>
-            <a:endParaRPr lang="en-US" altLang="zh-CN" sz="1600" dirty="0"/>
-          </a:p>
-          <a:p>
-            <a:pPr algn="ctr"/>
-            <a:r>
-              <a:rPr lang="zh-CN" altLang="en-US" sz="1600" dirty="0"/>
+            <a:endParaRPr lang="en-US" altLang="zh-CN" sz="1400" dirty="0"/>
+          </a:p>
+          <a:p>
+            <a:pPr algn="r"/>
+            <a:r>
+              <a:rPr lang="zh-CN" altLang="en-US" sz="1400" dirty="0"/>
               <a:t>四中全会</a:t>
             </a:r>
           </a:p>
@@ -4027,8 +4027,8 @@
         </p:nvSpPr>
         <p:spPr>
           <a:xfrm>
-            <a:off x="6146954" y="2095993"/>
-            <a:ext cx="1159589" cy="584775"/>
+            <a:off x="6222184" y="2106946"/>
+            <a:ext cx="1159589" cy="523220"/>
           </a:xfrm>
           <a:prstGeom prst="rect">
             <a:avLst/>
@@ -4041,17 +4041,17 @@
           </a:bodyPr>
           <a:lstStyle/>
           <a:p>
-            <a:pPr algn="ctr"/>
-            <a:r>
-              <a:rPr lang="zh-CN" altLang="en-US" sz="1600" dirty="0"/>
+            <a:pPr algn="r"/>
+            <a:r>
+              <a:rPr lang="zh-CN" altLang="en-US" sz="1400" dirty="0"/>
               <a:t>十九届</a:t>
             </a:r>
-            <a:endParaRPr lang="en-US" altLang="zh-CN" sz="1600" dirty="0"/>
-          </a:p>
-          <a:p>
-            <a:pPr algn="ctr"/>
-            <a:r>
-              <a:rPr lang="zh-CN" altLang="en-US" sz="1600" dirty="0"/>
+            <a:endParaRPr lang="en-US" altLang="zh-CN" sz="1400" dirty="0"/>
+          </a:p>
+          <a:p>
+            <a:pPr algn="r"/>
+            <a:r>
+              <a:rPr lang="zh-CN" altLang="en-US" sz="1400" dirty="0"/>
               <a:t>五中全会</a:t>
             </a:r>
           </a:p>
@@ -4071,8 +4071,8 @@
         </p:nvSpPr>
         <p:spPr>
           <a:xfrm>
-            <a:off x="7573463" y="2064616"/>
-            <a:ext cx="1202044" cy="584775"/>
+            <a:off x="7533698" y="2105470"/>
+            <a:ext cx="1202044" cy="523220"/>
           </a:xfrm>
           <a:prstGeom prst="rect">
             <a:avLst/>
@@ -4085,17 +4085,17 @@
           </a:bodyPr>
           <a:lstStyle/>
           <a:p>
-            <a:pPr algn="ctr"/>
-            <a:r>
-              <a:rPr lang="zh-CN" altLang="en-US" sz="1600" dirty="0"/>
+            <a:pPr algn="r"/>
+            <a:r>
+              <a:rPr lang="zh-CN" altLang="en-US" sz="1400" dirty="0"/>
               <a:t>十九届</a:t>
             </a:r>
-            <a:endParaRPr lang="en-US" altLang="zh-CN" sz="1600" dirty="0"/>
-          </a:p>
-          <a:p>
-            <a:pPr algn="ctr"/>
-            <a:r>
-              <a:rPr lang="zh-CN" altLang="en-US" sz="1600" dirty="0"/>
+            <a:endParaRPr lang="en-US" altLang="zh-CN" sz="1400" dirty="0"/>
+          </a:p>
+          <a:p>
+            <a:pPr algn="r"/>
+            <a:r>
+              <a:rPr lang="zh-CN" altLang="en-US" sz="1400" dirty="0"/>
               <a:t>六中全会</a:t>
             </a:r>
           </a:p>
@@ -4115,8 +4115,8 @@
         </p:nvSpPr>
         <p:spPr>
           <a:xfrm>
-            <a:off x="9052423" y="2093127"/>
-            <a:ext cx="1159589" cy="584775"/>
+            <a:off x="8946058" y="2111070"/>
+            <a:ext cx="1159589" cy="523220"/>
           </a:xfrm>
           <a:prstGeom prst="rect">
             <a:avLst/>
@@ -4129,17 +4129,17 @@
           </a:bodyPr>
           <a:lstStyle/>
           <a:p>
-            <a:pPr algn="ctr"/>
-            <a:r>
-              <a:rPr lang="zh-CN" altLang="en-US" sz="1600" dirty="0"/>
+            <a:pPr algn="r"/>
+            <a:r>
+              <a:rPr lang="zh-CN" altLang="en-US" sz="1400" dirty="0"/>
               <a:t>十九届</a:t>
             </a:r>
-            <a:endParaRPr lang="en-US" altLang="zh-CN" sz="1600" dirty="0"/>
-          </a:p>
-          <a:p>
-            <a:pPr algn="ctr"/>
-            <a:r>
-              <a:rPr lang="zh-CN" altLang="en-US" sz="1600" dirty="0"/>
+            <a:endParaRPr lang="en-US" altLang="zh-CN" sz="1400" dirty="0"/>
+          </a:p>
+          <a:p>
+            <a:pPr algn="r"/>
+            <a:r>
+              <a:rPr lang="zh-CN" altLang="en-US" sz="1400" dirty="0"/>
               <a:t>七中全会</a:t>
             </a:r>
           </a:p>
@@ -4206,7 +4206,7 @@
         </p:nvSpPr>
         <p:spPr>
           <a:xfrm>
-            <a:off x="10481328" y="3115842"/>
+            <a:off x="10528649" y="3088548"/>
             <a:ext cx="1076099" cy="584775"/>
           </a:xfrm>
           <a:prstGeom prst="rect">
@@ -4262,7 +4262,7 @@
         </p:nvSpPr>
         <p:spPr>
           <a:xfrm>
-            <a:off x="10151048" y="2581197"/>
+            <a:off x="10146484" y="2396729"/>
             <a:ext cx="1178155" cy="461665"/>
           </a:xfrm>
           <a:prstGeom prst="rect">
@@ -4349,7 +4349,7 @@
         <p:spPr>
           <a:xfrm>
             <a:off x="10791052" y="1850663"/>
-            <a:ext cx="1159588" cy="584775"/>
+            <a:ext cx="1159588" cy="523220"/>
           </a:xfrm>
           <a:prstGeom prst="rect">
             <a:avLst/>
@@ -4362,25 +4362,25 @@
           </a:bodyPr>
           <a:lstStyle/>
           <a:p>
-            <a:pPr algn="ctr"/>
-            <a:r>
-              <a:rPr lang="zh-CN" altLang="en-US" sz="1600" dirty="0">
+            <a:pPr algn="r"/>
+            <a:r>
+              <a:rPr lang="zh-CN" altLang="en-US" sz="1400" dirty="0">
                 <a:solidFill>
                   <a:srgbClr val="00B0F0"/>
                 </a:solidFill>
               </a:rPr>
               <a:t>二十届</a:t>
             </a:r>
-            <a:endParaRPr lang="en-US" altLang="zh-CN" sz="1600" dirty="0">
+            <a:endParaRPr lang="en-US" altLang="zh-CN" sz="1400" dirty="0">
               <a:solidFill>
                 <a:srgbClr val="00B0F0"/>
               </a:solidFill>
             </a:endParaRPr>
           </a:p>
           <a:p>
-            <a:pPr algn="ctr"/>
-            <a:r>
-              <a:rPr lang="zh-CN" altLang="en-US" sz="1600" dirty="0">
+            <a:pPr algn="r"/>
+            <a:r>
+              <a:rPr lang="zh-CN" altLang="en-US" sz="1400" dirty="0">
                 <a:solidFill>
                   <a:srgbClr val="00B0F0"/>
                 </a:solidFill>
@@ -4502,8 +4502,8 @@
         </p:nvCxnSpPr>
         <p:spPr>
           <a:xfrm flipH="1" flipV="1">
-            <a:off x="9898568" y="2740370"/>
-            <a:ext cx="960166" cy="1089800"/>
+            <a:off x="9788493" y="2629895"/>
+            <a:ext cx="1217755" cy="1216450"/>
           </a:xfrm>
           <a:prstGeom prst="line">
             <a:avLst/>
@@ -4776,7 +4776,7 @@
         </p:nvSpPr>
         <p:spPr>
           <a:xfrm>
-            <a:off x="9673434" y="3117782"/>
+            <a:off x="9640187" y="2983202"/>
             <a:ext cx="992424" cy="584775"/>
           </a:xfrm>
           <a:prstGeom prst="rect">
@@ -5758,7 +5758,7 @@
                 <a:latin typeface="楷体" panose="02010609060101010101" pitchFamily="49" charset="-122"/>
                 <a:ea typeface="楷体" panose="02010609060101010101" pitchFamily="49" charset="-122"/>
               </a:rPr>
-              <a:t>党的二十届中央委员会后补委员（</a:t>
+              <a:t>党的二十届中央委员会候补委员（</a:t>
             </a:r>
             <a:r>
               <a:rPr lang="en-US" altLang="zh-CN" sz="1200" dirty="0">
@@ -6263,6 +6263,127 @@
               </a:rPr>
               <a:t>人代会</a:t>
             </a:r>
+          </a:p>
+        </p:txBody>
+      </p:sp>
+      <p:cxnSp>
+        <p:nvCxnSpPr>
+          <p:cNvPr id="63" name="直接连接符 62">
+            <a:extLst>
+              <a:ext uri="{FF2B5EF4-FFF2-40B4-BE49-F238E27FC236}">
+                <a16:creationId xmlns:a16="http://schemas.microsoft.com/office/drawing/2014/main" id="{C98DAEFE-CEEA-4DBC-AD2D-1EAE26F42C7E}"/>
+              </a:ext>
+            </a:extLst>
+          </p:cNvPr>
+          <p:cNvCxnSpPr>
+            <a:cxnSpLocks/>
+          </p:cNvCxnSpPr>
+          <p:nvPr/>
+        </p:nvCxnSpPr>
+        <p:spPr>
+          <a:xfrm flipH="1" flipV="1">
+            <a:off x="1286122" y="3055286"/>
+            <a:ext cx="606067" cy="767539"/>
+          </a:xfrm>
+          <a:prstGeom prst="line">
+            <a:avLst/>
+          </a:prstGeom>
+          <a:ln w="28575">
+            <a:solidFill>
+              <a:schemeClr val="bg1">
+                <a:lumMod val="75000"/>
+                <a:alpha val="40000"/>
+              </a:schemeClr>
+            </a:solidFill>
+            <a:headEnd type="oval" w="lg" len="lg"/>
+            <a:tailEnd type="none"/>
+          </a:ln>
+        </p:spPr>
+        <p:style>
+          <a:lnRef idx="1">
+            <a:schemeClr val="accent1"/>
+          </a:lnRef>
+          <a:fillRef idx="0">
+            <a:schemeClr val="accent1"/>
+          </a:fillRef>
+          <a:effectRef idx="0">
+            <a:schemeClr val="accent1"/>
+          </a:effectRef>
+          <a:fontRef idx="minor">
+            <a:schemeClr val="tx1"/>
+          </a:fontRef>
+        </p:style>
+      </p:cxnSp>
+      <p:sp>
+        <p:nvSpPr>
+          <p:cNvPr id="71" name="文本框 70">
+            <a:extLst>
+              <a:ext uri="{FF2B5EF4-FFF2-40B4-BE49-F238E27FC236}">
+                <a16:creationId xmlns:a16="http://schemas.microsoft.com/office/drawing/2014/main" id="{3C386F94-C64B-4BD3-A46D-28E26431070F}"/>
+              </a:ext>
+            </a:extLst>
+          </p:cNvPr>
+          <p:cNvSpPr txBox="1"/>
+          <p:nvPr/>
+        </p:nvSpPr>
+        <p:spPr>
+          <a:xfrm>
+            <a:off x="322889" y="2959232"/>
+            <a:ext cx="1521304" cy="307777"/>
+          </a:xfrm>
+          <a:prstGeom prst="rect">
+            <a:avLst/>
+          </a:prstGeom>
+          <a:noFill/>
+        </p:spPr>
+        <p:txBody>
+          <a:bodyPr wrap="square" rtlCol="0">
+            <a:spAutoFit/>
+          </a:bodyPr>
+          <a:lstStyle/>
+          <a:p>
+            <a:pPr algn="r"/>
+            <a:r>
+              <a:rPr lang="zh-CN" altLang="en-US" sz="1400" dirty="0"/>
+              <a:t>十八届七中全会</a:t>
+            </a:r>
+          </a:p>
+        </p:txBody>
+      </p:sp>
+      <p:sp>
+        <p:nvSpPr>
+          <p:cNvPr id="72" name="文本框 71">
+            <a:extLst>
+              <a:ext uri="{FF2B5EF4-FFF2-40B4-BE49-F238E27FC236}">
+                <a16:creationId xmlns:a16="http://schemas.microsoft.com/office/drawing/2014/main" id="{B7D80E59-B9E7-4215-A69B-0C0A055DB3AB}"/>
+              </a:ext>
+            </a:extLst>
+          </p:cNvPr>
+          <p:cNvSpPr txBox="1"/>
+          <p:nvPr/>
+        </p:nvSpPr>
+        <p:spPr>
+          <a:xfrm>
+            <a:off x="446531" y="3213704"/>
+            <a:ext cx="1403073" cy="338554"/>
+          </a:xfrm>
+          <a:prstGeom prst="rect">
+            <a:avLst/>
+          </a:prstGeom>
+          <a:noFill/>
+        </p:spPr>
+        <p:txBody>
+          <a:bodyPr wrap="square" rtlCol="0">
+            <a:spAutoFit/>
+          </a:bodyPr>
+          <a:lstStyle/>
+          <a:p>
+            <a:pPr algn="r"/>
+            <a:r>
+              <a:rPr lang="en-US" altLang="zh-CN" sz="1600" dirty="0"/>
+              <a:t>2027.10.11-14</a:t>
+            </a:r>
+            <a:endParaRPr lang="zh-CN" altLang="en-US" sz="1600" dirty="0"/>
           </a:p>
         </p:txBody>
       </p:sp>

</xml_diff>